<commit_message>
an update to the notebook and the deployment package
</commit_message>
<xml_diff>
--- a/Capstone Project/Predicting_Contraceptive_Use_Presentation_Updated.pptx
+++ b/Capstone Project/Predicting_Contraceptive_Use_Presentation_Updated.pptx
@@ -5,37 +5,37 @@
     <p:sldMasterId id="2147483648" r:id="rId1"/>
   </p:sldMasterIdLst>
   <p:sldIdLst>
-    <p:sldId id="256" r:id="rId7"/>
-    <p:sldId id="257" r:id="rId8"/>
-    <p:sldId id="258" r:id="rId9"/>
-    <p:sldId id="259" r:id="rId10"/>
-    <p:sldId id="260" r:id="rId11"/>
-    <p:sldId id="261" r:id="rId12"/>
-    <p:sldId id="262" r:id="rId13"/>
-    <p:sldId id="263" r:id="rId14"/>
-    <p:sldId id="264" r:id="rId15"/>
-    <p:sldId id="265" r:id="rId16"/>
-    <p:sldId id="266" r:id="rId17"/>
-    <p:sldId id="267" r:id="rId18"/>
-    <p:sldId id="268" r:id="rId19"/>
-    <p:sldId id="269" r:id="rId20"/>
-    <p:sldId id="270" r:id="rId21"/>
-    <p:sldId id="271" r:id="rId22"/>
-    <p:sldId id="272" r:id="rId23"/>
-    <p:sldId id="273" r:id="rId24"/>
-    <p:sldId id="274" r:id="rId25"/>
-    <p:sldId id="275" r:id="rId26"/>
-    <p:sldId id="276" r:id="rId27"/>
-    <p:sldId id="277" r:id="rId28"/>
-    <p:sldId id="278" r:id="rId29"/>
-    <p:sldId id="279" r:id="rId30"/>
-    <p:sldId id="280" r:id="rId31"/>
-    <p:sldId id="281" r:id="rId32"/>
-    <p:sldId id="282" r:id="rId33"/>
-    <p:sldId id="283" r:id="rId34"/>
-    <p:sldId id="284" r:id="rId35"/>
+    <p:sldId id="256" r:id="rId2"/>
+    <p:sldId id="257" r:id="rId3"/>
+    <p:sldId id="258" r:id="rId4"/>
+    <p:sldId id="259" r:id="rId5"/>
+    <p:sldId id="260" r:id="rId6"/>
+    <p:sldId id="261" r:id="rId7"/>
+    <p:sldId id="262" r:id="rId8"/>
+    <p:sldId id="263" r:id="rId9"/>
+    <p:sldId id="264" r:id="rId10"/>
+    <p:sldId id="265" r:id="rId11"/>
+    <p:sldId id="266" r:id="rId12"/>
+    <p:sldId id="267" r:id="rId13"/>
+    <p:sldId id="268" r:id="rId14"/>
+    <p:sldId id="269" r:id="rId15"/>
+    <p:sldId id="270" r:id="rId16"/>
+    <p:sldId id="271" r:id="rId17"/>
+    <p:sldId id="272" r:id="rId18"/>
+    <p:sldId id="273" r:id="rId19"/>
+    <p:sldId id="274" r:id="rId20"/>
+    <p:sldId id="275" r:id="rId21"/>
+    <p:sldId id="276" r:id="rId22"/>
+    <p:sldId id="277" r:id="rId23"/>
+    <p:sldId id="278" r:id="rId24"/>
+    <p:sldId id="279" r:id="rId25"/>
+    <p:sldId id="280" r:id="rId26"/>
+    <p:sldId id="281" r:id="rId27"/>
+    <p:sldId id="282" r:id="rId28"/>
+    <p:sldId id="283" r:id="rId29"/>
+    <p:sldId id="284" r:id="rId30"/>
   </p:sldIdLst>
-  <p:sldSz cx="12191695" cy="6858000" type="screen4x3"/>
+  <p:sldSz cx="12192000" cy="6858000"/>
   <p:notesSz cx="6858000" cy="9144000"/>
   <p:defaultTextStyle>
     <a:defPPr>
@@ -132,6 +132,22 @@
       </a:defRPr>
     </a:lvl9pPr>
   </p:defaultTextStyle>
+  <p:extLst>
+    <p:ext uri="{EFAFB233-063F-42B5-8137-9DF3F51BA10A}">
+      <p15:sldGuideLst xmlns:p15="http://schemas.microsoft.com/office/powerpoint/2012/main">
+        <p15:guide id="1" orient="horz" pos="2160">
+          <p15:clr>
+            <a:srgbClr val="A4A3A4"/>
+          </p15:clr>
+        </p15:guide>
+        <p15:guide id="2" pos="2880">
+          <p15:clr>
+            <a:srgbClr val="A4A3A4"/>
+          </p15:clr>
+        </p15:guide>
+      </p15:sldGuideLst>
+    </p:ext>
+  </p:extLst>
 </p:presentation>
 </file>
 
@@ -173,10 +189,9 @@
           <a:lstStyle/>
           <a:p>
             <a:r>
-              <a:rPr lang="en-US" smtClean="0"/>
+              <a:rPr lang="en-US"/>
               <a:t>Click to edit Master title style</a:t>
             </a:r>
-            <a:endParaRPr lang="en-US"/>
           </a:p>
         </p:txBody>
       </p:sp>
@@ -292,10 +307,9 @@
           </a:lstStyle>
           <a:p>
             <a:r>
-              <a:rPr lang="en-US" smtClean="0"/>
+              <a:rPr lang="en-US"/>
               <a:t>Click to edit Master subtitle style</a:t>
             </a:r>
-            <a:endParaRPr lang="en-US"/>
           </a:p>
         </p:txBody>
       </p:sp>
@@ -316,7 +330,7 @@
           <a:p>
             <a:fld id="{5BCAD085-E8A6-8845-BD4E-CB4CCA059FC4}" type="datetimeFigureOut">
               <a:rPr lang="en-US" smtClean="0"/>
-              <a:t>1/27/13</a:t>
+              <a:t>7/14/2026</a:t>
             </a:fld>
             <a:endParaRPr lang="en-US"/>
           </a:p>
@@ -410,10 +424,9 @@
           <a:lstStyle/>
           <a:p>
             <a:r>
-              <a:rPr lang="en-US" smtClean="0"/>
+              <a:rPr lang="en-US"/>
               <a:t>Click to edit Master title style</a:t>
             </a:r>
-            <a:endParaRPr lang="en-US"/>
           </a:p>
         </p:txBody>
       </p:sp>
@@ -434,38 +447,37 @@
           <a:p>
             <a:pPr lvl="0"/>
             <a:r>
-              <a:rPr lang="en-US" smtClean="0"/>
+              <a:rPr lang="en-US"/>
               <a:t>Click to edit Master text styles</a:t>
             </a:r>
           </a:p>
           <a:p>
             <a:pPr lvl="1"/>
             <a:r>
-              <a:rPr lang="en-US" smtClean="0"/>
+              <a:rPr lang="en-US"/>
               <a:t>Second level</a:t>
             </a:r>
           </a:p>
           <a:p>
             <a:pPr lvl="2"/>
             <a:r>
-              <a:rPr lang="en-US" smtClean="0"/>
+              <a:rPr lang="en-US"/>
               <a:t>Third level</a:t>
             </a:r>
           </a:p>
           <a:p>
             <a:pPr lvl="3"/>
             <a:r>
-              <a:rPr lang="en-US" smtClean="0"/>
+              <a:rPr lang="en-US"/>
               <a:t>Fourth level</a:t>
             </a:r>
           </a:p>
           <a:p>
             <a:pPr lvl="4"/>
             <a:r>
-              <a:rPr lang="en-US" smtClean="0"/>
+              <a:rPr lang="en-US"/>
               <a:t>Fifth level</a:t>
             </a:r>
-            <a:endParaRPr lang="en-US"/>
           </a:p>
         </p:txBody>
       </p:sp>
@@ -486,7 +498,7 @@
           <a:p>
             <a:fld id="{5BCAD085-E8A6-8845-BD4E-CB4CCA059FC4}" type="datetimeFigureOut">
               <a:rPr lang="en-US" smtClean="0"/>
-              <a:t>1/27/13</a:t>
+              <a:t>7/14/2026</a:t>
             </a:fld>
             <a:endParaRPr lang="en-US"/>
           </a:p>
@@ -585,10 +597,9 @@
           <a:lstStyle/>
           <a:p>
             <a:r>
-              <a:rPr lang="en-US" smtClean="0"/>
+              <a:rPr lang="en-US"/>
               <a:t>Click to edit Master title style</a:t>
             </a:r>
-            <a:endParaRPr lang="en-US"/>
           </a:p>
         </p:txBody>
       </p:sp>
@@ -614,38 +625,37 @@
           <a:p>
             <a:pPr lvl="0"/>
             <a:r>
-              <a:rPr lang="en-US" smtClean="0"/>
+              <a:rPr lang="en-US"/>
               <a:t>Click to edit Master text styles</a:t>
             </a:r>
           </a:p>
           <a:p>
             <a:pPr lvl="1"/>
             <a:r>
-              <a:rPr lang="en-US" smtClean="0"/>
+              <a:rPr lang="en-US"/>
               <a:t>Second level</a:t>
             </a:r>
           </a:p>
           <a:p>
             <a:pPr lvl="2"/>
             <a:r>
-              <a:rPr lang="en-US" smtClean="0"/>
+              <a:rPr lang="en-US"/>
               <a:t>Third level</a:t>
             </a:r>
           </a:p>
           <a:p>
             <a:pPr lvl="3"/>
             <a:r>
-              <a:rPr lang="en-US" smtClean="0"/>
+              <a:rPr lang="en-US"/>
               <a:t>Fourth level</a:t>
             </a:r>
           </a:p>
           <a:p>
             <a:pPr lvl="4"/>
             <a:r>
-              <a:rPr lang="en-US" smtClean="0"/>
+              <a:rPr lang="en-US"/>
               <a:t>Fifth level</a:t>
             </a:r>
-            <a:endParaRPr lang="en-US"/>
           </a:p>
         </p:txBody>
       </p:sp>
@@ -666,7 +676,7 @@
           <a:p>
             <a:fld id="{5BCAD085-E8A6-8845-BD4E-CB4CCA059FC4}" type="datetimeFigureOut">
               <a:rPr lang="en-US" smtClean="0"/>
-              <a:t>1/27/13</a:t>
+              <a:t>7/14/2026</a:t>
             </a:fld>
             <a:endParaRPr lang="en-US"/>
           </a:p>
@@ -760,10 +770,9 @@
           <a:lstStyle/>
           <a:p>
             <a:r>
-              <a:rPr lang="en-US" smtClean="0"/>
+              <a:rPr lang="en-US"/>
               <a:t>Click to edit Master title style</a:t>
             </a:r>
-            <a:endParaRPr lang="en-US"/>
           </a:p>
         </p:txBody>
       </p:sp>
@@ -784,38 +793,37 @@
           <a:p>
             <a:pPr lvl="0"/>
             <a:r>
-              <a:rPr lang="en-US" smtClean="0"/>
+              <a:rPr lang="en-US"/>
               <a:t>Click to edit Master text styles</a:t>
             </a:r>
           </a:p>
           <a:p>
             <a:pPr lvl="1"/>
             <a:r>
-              <a:rPr lang="en-US" smtClean="0"/>
+              <a:rPr lang="en-US"/>
               <a:t>Second level</a:t>
             </a:r>
           </a:p>
           <a:p>
             <a:pPr lvl="2"/>
             <a:r>
-              <a:rPr lang="en-US" smtClean="0"/>
+              <a:rPr lang="en-US"/>
               <a:t>Third level</a:t>
             </a:r>
           </a:p>
           <a:p>
             <a:pPr lvl="3"/>
             <a:r>
-              <a:rPr lang="en-US" smtClean="0"/>
+              <a:rPr lang="en-US"/>
               <a:t>Fourth level</a:t>
             </a:r>
           </a:p>
           <a:p>
             <a:pPr lvl="4"/>
             <a:r>
-              <a:rPr lang="en-US" smtClean="0"/>
+              <a:rPr lang="en-US"/>
               <a:t>Fifth level</a:t>
             </a:r>
-            <a:endParaRPr lang="en-US"/>
           </a:p>
         </p:txBody>
       </p:sp>
@@ -836,7 +844,7 @@
           <a:p>
             <a:fld id="{5BCAD085-E8A6-8845-BD4E-CB4CCA059FC4}" type="datetimeFigureOut">
               <a:rPr lang="en-US" smtClean="0"/>
-              <a:t>1/27/13</a:t>
+              <a:t>7/14/2026</a:t>
             </a:fld>
             <a:endParaRPr lang="en-US"/>
           </a:p>
@@ -939,10 +947,9 @@
           </a:lstStyle>
           <a:p>
             <a:r>
-              <a:rPr lang="en-US" smtClean="0"/>
+              <a:rPr lang="en-US"/>
               <a:t>Click to edit Master title style</a:t>
             </a:r>
-            <a:endParaRPr lang="en-US"/>
           </a:p>
         </p:txBody>
       </p:sp>
@@ -1059,7 +1066,7 @@
           <a:p>
             <a:pPr lvl="0"/>
             <a:r>
-              <a:rPr lang="en-US" smtClean="0"/>
+              <a:rPr lang="en-US"/>
               <a:t>Click to edit Master text styles</a:t>
             </a:r>
           </a:p>
@@ -1082,7 +1089,7 @@
           <a:p>
             <a:fld id="{5BCAD085-E8A6-8845-BD4E-CB4CCA059FC4}" type="datetimeFigureOut">
               <a:rPr lang="en-US" smtClean="0"/>
-              <a:t>1/27/13</a:t>
+              <a:t>7/14/2026</a:t>
             </a:fld>
             <a:endParaRPr lang="en-US"/>
           </a:p>
@@ -1176,10 +1183,9 @@
           <a:lstStyle/>
           <a:p>
             <a:r>
-              <a:rPr lang="en-US" smtClean="0"/>
+              <a:rPr lang="en-US"/>
               <a:t>Click to edit Master title style</a:t>
             </a:r>
-            <a:endParaRPr lang="en-US"/>
           </a:p>
         </p:txBody>
       </p:sp>
@@ -1233,38 +1239,37 @@
           <a:p>
             <a:pPr lvl="0"/>
             <a:r>
-              <a:rPr lang="en-US" smtClean="0"/>
+              <a:rPr lang="en-US"/>
               <a:t>Click to edit Master text styles</a:t>
             </a:r>
           </a:p>
           <a:p>
             <a:pPr lvl="1"/>
             <a:r>
-              <a:rPr lang="en-US" smtClean="0"/>
+              <a:rPr lang="en-US"/>
               <a:t>Second level</a:t>
             </a:r>
           </a:p>
           <a:p>
             <a:pPr lvl="2"/>
             <a:r>
-              <a:rPr lang="en-US" smtClean="0"/>
+              <a:rPr lang="en-US"/>
               <a:t>Third level</a:t>
             </a:r>
           </a:p>
           <a:p>
             <a:pPr lvl="3"/>
             <a:r>
-              <a:rPr lang="en-US" smtClean="0"/>
+              <a:rPr lang="en-US"/>
               <a:t>Fourth level</a:t>
             </a:r>
           </a:p>
           <a:p>
             <a:pPr lvl="4"/>
             <a:r>
-              <a:rPr lang="en-US" smtClean="0"/>
+              <a:rPr lang="en-US"/>
               <a:t>Fifth level</a:t>
             </a:r>
-            <a:endParaRPr lang="en-US"/>
           </a:p>
         </p:txBody>
       </p:sp>
@@ -1318,38 +1323,37 @@
           <a:p>
             <a:pPr lvl="0"/>
             <a:r>
-              <a:rPr lang="en-US" smtClean="0"/>
+              <a:rPr lang="en-US"/>
               <a:t>Click to edit Master text styles</a:t>
             </a:r>
           </a:p>
           <a:p>
             <a:pPr lvl="1"/>
             <a:r>
-              <a:rPr lang="en-US" smtClean="0"/>
+              <a:rPr lang="en-US"/>
               <a:t>Second level</a:t>
             </a:r>
           </a:p>
           <a:p>
             <a:pPr lvl="2"/>
             <a:r>
-              <a:rPr lang="en-US" smtClean="0"/>
+              <a:rPr lang="en-US"/>
               <a:t>Third level</a:t>
             </a:r>
           </a:p>
           <a:p>
             <a:pPr lvl="3"/>
             <a:r>
-              <a:rPr lang="en-US" smtClean="0"/>
+              <a:rPr lang="en-US"/>
               <a:t>Fourth level</a:t>
             </a:r>
           </a:p>
           <a:p>
             <a:pPr lvl="4"/>
             <a:r>
-              <a:rPr lang="en-US" smtClean="0"/>
+              <a:rPr lang="en-US"/>
               <a:t>Fifth level</a:t>
             </a:r>
-            <a:endParaRPr lang="en-US"/>
           </a:p>
         </p:txBody>
       </p:sp>
@@ -1370,7 +1374,7 @@
           <a:p>
             <a:fld id="{5BCAD085-E8A6-8845-BD4E-CB4CCA059FC4}" type="datetimeFigureOut">
               <a:rPr lang="en-US" smtClean="0"/>
-              <a:t>1/27/13</a:t>
+              <a:t>7/14/2026</a:t>
             </a:fld>
             <a:endParaRPr lang="en-US"/>
           </a:p>
@@ -1468,10 +1472,9 @@
           </a:lstStyle>
           <a:p>
             <a:r>
-              <a:rPr lang="en-US" smtClean="0"/>
+              <a:rPr lang="en-US"/>
               <a:t>Click to edit Master title style</a:t>
             </a:r>
-            <a:endParaRPr lang="en-US"/>
           </a:p>
         </p:txBody>
       </p:sp>
@@ -1534,7 +1537,7 @@
           <a:p>
             <a:pPr lvl="0"/>
             <a:r>
-              <a:rPr lang="en-US" smtClean="0"/>
+              <a:rPr lang="en-US"/>
               <a:t>Click to edit Master text styles</a:t>
             </a:r>
           </a:p>
@@ -1590,38 +1593,37 @@
           <a:p>
             <a:pPr lvl="0"/>
             <a:r>
-              <a:rPr lang="en-US" smtClean="0"/>
+              <a:rPr lang="en-US"/>
               <a:t>Click to edit Master text styles</a:t>
             </a:r>
           </a:p>
           <a:p>
             <a:pPr lvl="1"/>
             <a:r>
-              <a:rPr lang="en-US" smtClean="0"/>
+              <a:rPr lang="en-US"/>
               <a:t>Second level</a:t>
             </a:r>
           </a:p>
           <a:p>
             <a:pPr lvl="2"/>
             <a:r>
-              <a:rPr lang="en-US" smtClean="0"/>
+              <a:rPr lang="en-US"/>
               <a:t>Third level</a:t>
             </a:r>
           </a:p>
           <a:p>
             <a:pPr lvl="3"/>
             <a:r>
-              <a:rPr lang="en-US" smtClean="0"/>
+              <a:rPr lang="en-US"/>
               <a:t>Fourth level</a:t>
             </a:r>
           </a:p>
           <a:p>
             <a:pPr lvl="4"/>
             <a:r>
-              <a:rPr lang="en-US" smtClean="0"/>
+              <a:rPr lang="en-US"/>
               <a:t>Fifth level</a:t>
             </a:r>
-            <a:endParaRPr lang="en-US"/>
           </a:p>
         </p:txBody>
       </p:sp>
@@ -1684,7 +1686,7 @@
           <a:p>
             <a:pPr lvl="0"/>
             <a:r>
-              <a:rPr lang="en-US" smtClean="0"/>
+              <a:rPr lang="en-US"/>
               <a:t>Click to edit Master text styles</a:t>
             </a:r>
           </a:p>
@@ -1740,38 +1742,37 @@
           <a:p>
             <a:pPr lvl="0"/>
             <a:r>
-              <a:rPr lang="en-US" smtClean="0"/>
+              <a:rPr lang="en-US"/>
               <a:t>Click to edit Master text styles</a:t>
             </a:r>
           </a:p>
           <a:p>
             <a:pPr lvl="1"/>
             <a:r>
-              <a:rPr lang="en-US" smtClean="0"/>
+              <a:rPr lang="en-US"/>
               <a:t>Second level</a:t>
             </a:r>
           </a:p>
           <a:p>
             <a:pPr lvl="2"/>
             <a:r>
-              <a:rPr lang="en-US" smtClean="0"/>
+              <a:rPr lang="en-US"/>
               <a:t>Third level</a:t>
             </a:r>
           </a:p>
           <a:p>
             <a:pPr lvl="3"/>
             <a:r>
-              <a:rPr lang="en-US" smtClean="0"/>
+              <a:rPr lang="en-US"/>
               <a:t>Fourth level</a:t>
             </a:r>
           </a:p>
           <a:p>
             <a:pPr lvl="4"/>
             <a:r>
-              <a:rPr lang="en-US" smtClean="0"/>
+              <a:rPr lang="en-US"/>
               <a:t>Fifth level</a:t>
             </a:r>
-            <a:endParaRPr lang="en-US"/>
           </a:p>
         </p:txBody>
       </p:sp>
@@ -1792,7 +1793,7 @@
           <a:p>
             <a:fld id="{5BCAD085-E8A6-8845-BD4E-CB4CCA059FC4}" type="datetimeFigureOut">
               <a:rPr lang="en-US" smtClean="0"/>
-              <a:t>1/27/13</a:t>
+              <a:t>7/14/2026</a:t>
             </a:fld>
             <a:endParaRPr lang="en-US"/>
           </a:p>
@@ -1886,10 +1887,9 @@
           <a:lstStyle/>
           <a:p>
             <a:r>
-              <a:rPr lang="en-US" smtClean="0"/>
+              <a:rPr lang="en-US"/>
               <a:t>Click to edit Master title style</a:t>
             </a:r>
-            <a:endParaRPr lang="en-US"/>
           </a:p>
         </p:txBody>
       </p:sp>
@@ -1910,7 +1910,7 @@
           <a:p>
             <a:fld id="{5BCAD085-E8A6-8845-BD4E-CB4CCA059FC4}" type="datetimeFigureOut">
               <a:rPr lang="en-US" smtClean="0"/>
-              <a:t>1/27/13</a:t>
+              <a:t>7/14/2026</a:t>
             </a:fld>
             <a:endParaRPr lang="en-US"/>
           </a:p>
@@ -2005,7 +2005,7 @@
           <a:p>
             <a:fld id="{5BCAD085-E8A6-8845-BD4E-CB4CCA059FC4}" type="datetimeFigureOut">
               <a:rPr lang="en-US" smtClean="0"/>
-              <a:t>1/27/13</a:t>
+              <a:t>7/14/2026</a:t>
             </a:fld>
             <a:endParaRPr lang="en-US"/>
           </a:p>
@@ -2108,10 +2108,9 @@
           </a:lstStyle>
           <a:p>
             <a:r>
-              <a:rPr lang="en-US" smtClean="0"/>
+              <a:rPr lang="en-US"/>
               <a:t>Click to edit Master title style</a:t>
             </a:r>
-            <a:endParaRPr lang="en-US"/>
           </a:p>
         </p:txBody>
       </p:sp>
@@ -2165,38 +2164,37 @@
           <a:p>
             <a:pPr lvl="0"/>
             <a:r>
-              <a:rPr lang="en-US" smtClean="0"/>
+              <a:rPr lang="en-US"/>
               <a:t>Click to edit Master text styles</a:t>
             </a:r>
           </a:p>
           <a:p>
             <a:pPr lvl="1"/>
             <a:r>
-              <a:rPr lang="en-US" smtClean="0"/>
+              <a:rPr lang="en-US"/>
               <a:t>Second level</a:t>
             </a:r>
           </a:p>
           <a:p>
             <a:pPr lvl="2"/>
             <a:r>
-              <a:rPr lang="en-US" smtClean="0"/>
+              <a:rPr lang="en-US"/>
               <a:t>Third level</a:t>
             </a:r>
           </a:p>
           <a:p>
             <a:pPr lvl="3"/>
             <a:r>
-              <a:rPr lang="en-US" smtClean="0"/>
+              <a:rPr lang="en-US"/>
               <a:t>Fourth level</a:t>
             </a:r>
           </a:p>
           <a:p>
             <a:pPr lvl="4"/>
             <a:r>
-              <a:rPr lang="en-US" smtClean="0"/>
+              <a:rPr lang="en-US"/>
               <a:t>Fifth level</a:t>
             </a:r>
-            <a:endParaRPr lang="en-US"/>
           </a:p>
         </p:txBody>
       </p:sp>
@@ -2259,7 +2257,7 @@
           <a:p>
             <a:pPr lvl="0"/>
             <a:r>
-              <a:rPr lang="en-US" smtClean="0"/>
+              <a:rPr lang="en-US"/>
               <a:t>Click to edit Master text styles</a:t>
             </a:r>
           </a:p>
@@ -2282,7 +2280,7 @@
           <a:p>
             <a:fld id="{5BCAD085-E8A6-8845-BD4E-CB4CCA059FC4}" type="datetimeFigureOut">
               <a:rPr lang="en-US" smtClean="0"/>
-              <a:t>1/27/13</a:t>
+              <a:t>7/14/2026</a:t>
             </a:fld>
             <a:endParaRPr lang="en-US"/>
           </a:p>
@@ -2385,10 +2383,9 @@
           </a:lstStyle>
           <a:p>
             <a:r>
-              <a:rPr lang="en-US" smtClean="0"/>
+              <a:rPr lang="en-US"/>
               <a:t>Click to edit Master title style</a:t>
             </a:r>
-            <a:endParaRPr lang="en-US"/>
           </a:p>
         </p:txBody>
       </p:sp>
@@ -2512,7 +2509,7 @@
           <a:p>
             <a:pPr lvl="0"/>
             <a:r>
-              <a:rPr lang="en-US" smtClean="0"/>
+              <a:rPr lang="en-US"/>
               <a:t>Click to edit Master text styles</a:t>
             </a:r>
           </a:p>
@@ -2535,7 +2532,7 @@
           <a:p>
             <a:fld id="{5BCAD085-E8A6-8845-BD4E-CB4CCA059FC4}" type="datetimeFigureOut">
               <a:rPr lang="en-US" smtClean="0"/>
-              <a:t>1/27/13</a:t>
+              <a:t>7/14/2026</a:t>
             </a:fld>
             <a:endParaRPr lang="en-US"/>
           </a:p>
@@ -2644,10 +2641,9 @@
           <a:lstStyle/>
           <a:p>
             <a:r>
-              <a:rPr lang="en-US" smtClean="0"/>
+              <a:rPr lang="en-US"/>
               <a:t>Click to edit Master title style</a:t>
             </a:r>
-            <a:endParaRPr lang="en-US"/>
           </a:p>
         </p:txBody>
       </p:sp>
@@ -2678,38 +2674,37 @@
           <a:p>
             <a:pPr lvl="0"/>
             <a:r>
-              <a:rPr lang="en-US" smtClean="0"/>
+              <a:rPr lang="en-US"/>
               <a:t>Click to edit Master text styles</a:t>
             </a:r>
           </a:p>
           <a:p>
             <a:pPr lvl="1"/>
             <a:r>
-              <a:rPr lang="en-US" smtClean="0"/>
+              <a:rPr lang="en-US"/>
               <a:t>Second level</a:t>
             </a:r>
           </a:p>
           <a:p>
             <a:pPr lvl="2"/>
             <a:r>
-              <a:rPr lang="en-US" smtClean="0"/>
+              <a:rPr lang="en-US"/>
               <a:t>Third level</a:t>
             </a:r>
           </a:p>
           <a:p>
             <a:pPr lvl="3"/>
             <a:r>
-              <a:rPr lang="en-US" smtClean="0"/>
+              <a:rPr lang="en-US"/>
               <a:t>Fourth level</a:t>
             </a:r>
           </a:p>
           <a:p>
             <a:pPr lvl="4"/>
             <a:r>
-              <a:rPr lang="en-US" smtClean="0"/>
+              <a:rPr lang="en-US"/>
               <a:t>Fifth level</a:t>
             </a:r>
-            <a:endParaRPr lang="en-US"/>
           </a:p>
         </p:txBody>
       </p:sp>
@@ -2748,7 +2743,7 @@
           <a:p>
             <a:fld id="{5BCAD085-E8A6-8845-BD4E-CB4CCA059FC4}" type="datetimeFigureOut">
               <a:rPr lang="en-US" smtClean="0"/>
-              <a:t>1/27/13</a:t>
+              <a:t>7/14/2026</a:t>
             </a:fld>
             <a:endParaRPr lang="en-US"/>
           </a:p>
@@ -3107,7 +3102,7 @@
 </file>
 
 <file path=ppt/slides/slide1.xml><?xml version="1.0" encoding="utf-8"?>
-<p:sld xmlns:a="http://schemas.openxmlformats.org/drawingml/2006/main" xmlns:p="http://schemas.openxmlformats.org/presentationml/2006/main" xmlns:r="http://schemas.openxmlformats.org/officeDocument/2006/relationships">
+<p:sld xmlns:a="http://schemas.openxmlformats.org/drawingml/2006/main" xmlns:r="http://schemas.openxmlformats.org/officeDocument/2006/relationships" xmlns:p="http://schemas.openxmlformats.org/presentationml/2006/main">
   <p:cSld>
     <p:bg>
       <p:bgPr>
@@ -3123,7 +3118,14 @@
         <p:cNvGrpSpPr/>
         <p:nvPr/>
       </p:nvGrpSpPr>
-      <p:grpSpPr/>
+      <p:grpSpPr>
+        <a:xfrm>
+          <a:off x="0" y="0"/>
+          <a:ext cx="0" cy="0"/>
+          <a:chOff x="0" y="0"/>
+          <a:chExt cx="0" cy="0"/>
+        </a:xfrm>
+      </p:grpSpPr>
       <p:sp>
         <p:nvSpPr>
           <p:cNvPr id="2" name="Rectangle 1"/>
@@ -3164,6 +3166,7 @@
           <a:lstStyle/>
           <a:p>
             <a:pPr algn="ctr"/>
+            <a:endParaRPr/>
           </a:p>
         </p:txBody>
       </p:sp>
@@ -3207,6 +3210,7 @@
           <a:lstStyle/>
           <a:p>
             <a:pPr algn="ctr"/>
+            <a:endParaRPr/>
           </a:p>
         </p:txBody>
       </p:sp>
@@ -3405,7 +3409,7 @@
 </file>
 
 <file path=ppt/slides/slide10.xml><?xml version="1.0" encoding="utf-8"?>
-<p:sld xmlns:a="http://schemas.openxmlformats.org/drawingml/2006/main" xmlns:p="http://schemas.openxmlformats.org/presentationml/2006/main" xmlns:r="http://schemas.openxmlformats.org/officeDocument/2006/relationships">
+<p:sld xmlns:a="http://schemas.openxmlformats.org/drawingml/2006/main" xmlns:r="http://schemas.openxmlformats.org/officeDocument/2006/relationships" xmlns:p="http://schemas.openxmlformats.org/presentationml/2006/main">
   <p:cSld>
     <p:bg>
       <p:bgPr>
@@ -3421,7 +3425,14 @@
         <p:cNvGrpSpPr/>
         <p:nvPr/>
       </p:nvGrpSpPr>
-      <p:grpSpPr/>
+      <p:grpSpPr>
+        <a:xfrm>
+          <a:off x="0" y="0"/>
+          <a:ext cx="0" cy="0"/>
+          <a:chOff x="0" y="0"/>
+          <a:chExt cx="0" cy="0"/>
+        </a:xfrm>
+      </p:grpSpPr>
       <p:sp>
         <p:nvSpPr>
           <p:cNvPr id="2" name="Rectangle 1"/>
@@ -3462,6 +3473,7 @@
           <a:lstStyle/>
           <a:p>
             <a:pPr algn="ctr"/>
+            <a:endParaRPr/>
           </a:p>
         </p:txBody>
       </p:sp>
@@ -3505,6 +3517,7 @@
           <a:lstStyle/>
           <a:p>
             <a:pPr algn="ctr"/>
+            <a:endParaRPr/>
           </a:p>
         </p:txBody>
       </p:sp>
@@ -3615,6 +3628,7 @@
           <a:lstStyle/>
           <a:p>
             <a:pPr algn="ctr"/>
+            <a:endParaRPr/>
           </a:p>
         </p:txBody>
       </p:sp>
@@ -3712,6 +3726,7 @@
           <a:lstStyle/>
           <a:p>
             <a:pPr algn="ctr"/>
+            <a:endParaRPr/>
           </a:p>
         </p:txBody>
       </p:sp>
@@ -3919,6 +3934,7 @@
           <a:lstStyle/>
           <a:p>
             <a:pPr algn="ctr"/>
+            <a:endParaRPr/>
           </a:p>
         </p:txBody>
       </p:sp>
@@ -3955,7 +3971,7 @@
 </file>
 
 <file path=ppt/slides/slide11.xml><?xml version="1.0" encoding="utf-8"?>
-<p:sld xmlns:a="http://schemas.openxmlformats.org/drawingml/2006/main" xmlns:p="http://schemas.openxmlformats.org/presentationml/2006/main" xmlns:r="http://schemas.openxmlformats.org/officeDocument/2006/relationships">
+<p:sld xmlns:a="http://schemas.openxmlformats.org/drawingml/2006/main" xmlns:r="http://schemas.openxmlformats.org/officeDocument/2006/relationships" xmlns:p="http://schemas.openxmlformats.org/presentationml/2006/main">
   <p:cSld>
     <p:bg>
       <p:bgPr>
@@ -3971,7 +3987,14 @@
         <p:cNvGrpSpPr/>
         <p:nvPr/>
       </p:nvGrpSpPr>
-      <p:grpSpPr/>
+      <p:grpSpPr>
+        <a:xfrm>
+          <a:off x="0" y="0"/>
+          <a:ext cx="0" cy="0"/>
+          <a:chOff x="0" y="0"/>
+          <a:chExt cx="0" cy="0"/>
+        </a:xfrm>
+      </p:grpSpPr>
       <p:sp>
         <p:nvSpPr>
           <p:cNvPr id="2" name="Rectangle 1"/>
@@ -4012,6 +4035,7 @@
           <a:lstStyle/>
           <a:p>
             <a:pPr algn="ctr"/>
+            <a:endParaRPr/>
           </a:p>
         </p:txBody>
       </p:sp>
@@ -4055,6 +4079,7 @@
           <a:lstStyle/>
           <a:p>
             <a:pPr algn="ctr"/>
+            <a:endParaRPr/>
           </a:p>
         </p:txBody>
       </p:sp>
@@ -4165,6 +4190,7 @@
           <a:lstStyle/>
           <a:p>
             <a:pPr algn="ctr"/>
+            <a:endParaRPr/>
           </a:p>
         </p:txBody>
       </p:sp>
@@ -4262,6 +4288,7 @@
           <a:lstStyle/>
           <a:p>
             <a:pPr algn="ctr"/>
+            <a:endParaRPr/>
           </a:p>
         </p:txBody>
       </p:sp>
@@ -4447,6 +4474,7 @@
           <a:lstStyle/>
           <a:p>
             <a:pPr algn="ctr"/>
+            <a:endParaRPr/>
           </a:p>
         </p:txBody>
       </p:sp>
@@ -4483,7 +4511,7 @@
 </file>
 
 <file path=ppt/slides/slide12.xml><?xml version="1.0" encoding="utf-8"?>
-<p:sld xmlns:a="http://schemas.openxmlformats.org/drawingml/2006/main" xmlns:p="http://schemas.openxmlformats.org/presentationml/2006/main" xmlns:r="http://schemas.openxmlformats.org/officeDocument/2006/relationships">
+<p:sld xmlns:a="http://schemas.openxmlformats.org/drawingml/2006/main" xmlns:r="http://schemas.openxmlformats.org/officeDocument/2006/relationships" xmlns:p="http://schemas.openxmlformats.org/presentationml/2006/main">
   <p:cSld>
     <p:bg>
       <p:bgPr>
@@ -4499,7 +4527,14 @@
         <p:cNvGrpSpPr/>
         <p:nvPr/>
       </p:nvGrpSpPr>
-      <p:grpSpPr/>
+      <p:grpSpPr>
+        <a:xfrm>
+          <a:off x="0" y="0"/>
+          <a:ext cx="0" cy="0"/>
+          <a:chOff x="0" y="0"/>
+          <a:chExt cx="0" cy="0"/>
+        </a:xfrm>
+      </p:grpSpPr>
       <p:sp>
         <p:nvSpPr>
           <p:cNvPr id="2" name="Rectangle 1"/>
@@ -4540,6 +4575,7 @@
           <a:lstStyle/>
           <a:p>
             <a:pPr algn="ctr"/>
+            <a:endParaRPr/>
           </a:p>
         </p:txBody>
       </p:sp>
@@ -4583,6 +4619,7 @@
           <a:lstStyle/>
           <a:p>
             <a:pPr algn="ctr"/>
+            <a:endParaRPr/>
           </a:p>
         </p:txBody>
       </p:sp>
@@ -4693,6 +4730,7 @@
           <a:lstStyle/>
           <a:p>
             <a:pPr algn="ctr"/>
+            <a:endParaRPr/>
           </a:p>
         </p:txBody>
       </p:sp>
@@ -4790,6 +4828,7 @@
           <a:lstStyle/>
           <a:p>
             <a:pPr algn="ctr"/>
+            <a:endParaRPr/>
           </a:p>
         </p:txBody>
       </p:sp>
@@ -5019,6 +5058,7 @@
           <a:lstStyle/>
           <a:p>
             <a:pPr algn="ctr"/>
+            <a:endParaRPr/>
           </a:p>
         </p:txBody>
       </p:sp>
@@ -5055,7 +5095,7 @@
 </file>
 
 <file path=ppt/slides/slide13.xml><?xml version="1.0" encoding="utf-8"?>
-<p:sld xmlns:a="http://schemas.openxmlformats.org/drawingml/2006/main" xmlns:p="http://schemas.openxmlformats.org/presentationml/2006/main" xmlns:r="http://schemas.openxmlformats.org/officeDocument/2006/relationships">
+<p:sld xmlns:a="http://schemas.openxmlformats.org/drawingml/2006/main" xmlns:r="http://schemas.openxmlformats.org/officeDocument/2006/relationships" xmlns:p="http://schemas.openxmlformats.org/presentationml/2006/main">
   <p:cSld>
     <p:bg>
       <p:bgPr>
@@ -5071,7 +5111,14 @@
         <p:cNvGrpSpPr/>
         <p:nvPr/>
       </p:nvGrpSpPr>
-      <p:grpSpPr/>
+      <p:grpSpPr>
+        <a:xfrm>
+          <a:off x="0" y="0"/>
+          <a:ext cx="0" cy="0"/>
+          <a:chOff x="0" y="0"/>
+          <a:chExt cx="0" cy="0"/>
+        </a:xfrm>
+      </p:grpSpPr>
       <p:sp>
         <p:nvSpPr>
           <p:cNvPr id="2" name="Rectangle 1"/>
@@ -5112,6 +5159,7 @@
           <a:lstStyle/>
           <a:p>
             <a:pPr algn="ctr"/>
+            <a:endParaRPr/>
           </a:p>
         </p:txBody>
       </p:sp>
@@ -5155,6 +5203,7 @@
           <a:lstStyle/>
           <a:p>
             <a:pPr algn="ctr"/>
+            <a:endParaRPr/>
           </a:p>
         </p:txBody>
       </p:sp>
@@ -5234,7 +5283,7 @@
 </file>
 
 <file path=ppt/slides/slide14.xml><?xml version="1.0" encoding="utf-8"?>
-<p:sld xmlns:a="http://schemas.openxmlformats.org/drawingml/2006/main" xmlns:p="http://schemas.openxmlformats.org/presentationml/2006/main" xmlns:r="http://schemas.openxmlformats.org/officeDocument/2006/relationships">
+<p:sld xmlns:a="http://schemas.openxmlformats.org/drawingml/2006/main" xmlns:r="http://schemas.openxmlformats.org/officeDocument/2006/relationships" xmlns:p="http://schemas.openxmlformats.org/presentationml/2006/main">
   <p:cSld>
     <p:bg>
       <p:bgPr>
@@ -5250,7 +5299,14 @@
         <p:cNvGrpSpPr/>
         <p:nvPr/>
       </p:nvGrpSpPr>
-      <p:grpSpPr/>
+      <p:grpSpPr>
+        <a:xfrm>
+          <a:off x="0" y="0"/>
+          <a:ext cx="0" cy="0"/>
+          <a:chOff x="0" y="0"/>
+          <a:chExt cx="0" cy="0"/>
+        </a:xfrm>
+      </p:grpSpPr>
       <p:sp>
         <p:nvSpPr>
           <p:cNvPr id="2" name="Rectangle 1"/>
@@ -5291,6 +5347,7 @@
           <a:lstStyle/>
           <a:p>
             <a:pPr algn="ctr"/>
+            <a:endParaRPr/>
           </a:p>
         </p:txBody>
       </p:sp>
@@ -5334,6 +5391,7 @@
           <a:lstStyle/>
           <a:p>
             <a:pPr algn="ctr"/>
+            <a:endParaRPr/>
           </a:p>
         </p:txBody>
       </p:sp>
@@ -5444,6 +5502,7 @@
           <a:lstStyle/>
           <a:p>
             <a:pPr algn="ctr"/>
+            <a:endParaRPr/>
           </a:p>
         </p:txBody>
       </p:sp>
@@ -5541,6 +5600,7 @@
           <a:lstStyle/>
           <a:p>
             <a:pPr algn="ctr"/>
+            <a:endParaRPr/>
           </a:p>
         </p:txBody>
       </p:sp>
@@ -5792,6 +5852,7 @@
           <a:lstStyle/>
           <a:p>
             <a:pPr algn="ctr"/>
+            <a:endParaRPr/>
           </a:p>
         </p:txBody>
       </p:sp>
@@ -5989,7 +6050,7 @@
 </file>
 
 <file path=ppt/slides/slide15.xml><?xml version="1.0" encoding="utf-8"?>
-<p:sld xmlns:a="http://schemas.openxmlformats.org/drawingml/2006/main" xmlns:p="http://schemas.openxmlformats.org/presentationml/2006/main" xmlns:r="http://schemas.openxmlformats.org/officeDocument/2006/relationships">
+<p:sld xmlns:a="http://schemas.openxmlformats.org/drawingml/2006/main" xmlns:r="http://schemas.openxmlformats.org/officeDocument/2006/relationships" xmlns:p="http://schemas.openxmlformats.org/presentationml/2006/main">
   <p:cSld>
     <p:bg>
       <p:bgPr>
@@ -6005,7 +6066,14 @@
         <p:cNvGrpSpPr/>
         <p:nvPr/>
       </p:nvGrpSpPr>
-      <p:grpSpPr/>
+      <p:grpSpPr>
+        <a:xfrm>
+          <a:off x="0" y="0"/>
+          <a:ext cx="0" cy="0"/>
+          <a:chOff x="0" y="0"/>
+          <a:chExt cx="0" cy="0"/>
+        </a:xfrm>
+      </p:grpSpPr>
       <p:sp>
         <p:nvSpPr>
           <p:cNvPr id="2" name="Rectangle 1"/>
@@ -6046,6 +6114,7 @@
           <a:lstStyle/>
           <a:p>
             <a:pPr algn="ctr"/>
+            <a:endParaRPr/>
           </a:p>
         </p:txBody>
       </p:sp>
@@ -6089,6 +6158,7 @@
           <a:lstStyle/>
           <a:p>
             <a:pPr algn="ctr"/>
+            <a:endParaRPr/>
           </a:p>
         </p:txBody>
       </p:sp>
@@ -6199,6 +6269,7 @@
           <a:lstStyle/>
           <a:p>
             <a:pPr algn="ctr"/>
+            <a:endParaRPr/>
           </a:p>
         </p:txBody>
       </p:sp>
@@ -6296,6 +6367,7 @@
           <a:lstStyle/>
           <a:p>
             <a:pPr algn="ctr"/>
+            <a:endParaRPr/>
           </a:p>
         </p:txBody>
       </p:sp>
@@ -6525,6 +6597,7 @@
           <a:lstStyle/>
           <a:p>
             <a:pPr algn="ctr"/>
+            <a:endParaRPr/>
           </a:p>
         </p:txBody>
       </p:sp>
@@ -6758,7 +6831,7 @@
 </file>
 
 <file path=ppt/slides/slide16.xml><?xml version="1.0" encoding="utf-8"?>
-<p:sld xmlns:a="http://schemas.openxmlformats.org/drawingml/2006/main" xmlns:p="http://schemas.openxmlformats.org/presentationml/2006/main" xmlns:r="http://schemas.openxmlformats.org/officeDocument/2006/relationships">
+<p:sld xmlns:a="http://schemas.openxmlformats.org/drawingml/2006/main" xmlns:r="http://schemas.openxmlformats.org/officeDocument/2006/relationships" xmlns:p="http://schemas.openxmlformats.org/presentationml/2006/main">
   <p:cSld>
     <p:bg>
       <p:bgPr>
@@ -6774,7 +6847,14 @@
         <p:cNvGrpSpPr/>
         <p:nvPr/>
       </p:nvGrpSpPr>
-      <p:grpSpPr/>
+      <p:grpSpPr>
+        <a:xfrm>
+          <a:off x="0" y="0"/>
+          <a:ext cx="0" cy="0"/>
+          <a:chOff x="0" y="0"/>
+          <a:chExt cx="0" cy="0"/>
+        </a:xfrm>
+      </p:grpSpPr>
       <p:sp>
         <p:nvSpPr>
           <p:cNvPr id="2" name="Rectangle 1"/>
@@ -6815,6 +6895,7 @@
           <a:lstStyle/>
           <a:p>
             <a:pPr algn="ctr"/>
+            <a:endParaRPr/>
           </a:p>
         </p:txBody>
       </p:sp>
@@ -6858,6 +6939,7 @@
           <a:lstStyle/>
           <a:p>
             <a:pPr algn="ctr"/>
+            <a:endParaRPr/>
           </a:p>
         </p:txBody>
       </p:sp>
@@ -6937,7 +7019,7 @@
 </file>
 
 <file path=ppt/slides/slide17.xml><?xml version="1.0" encoding="utf-8"?>
-<p:sld xmlns:a="http://schemas.openxmlformats.org/drawingml/2006/main" xmlns:p="http://schemas.openxmlformats.org/presentationml/2006/main" xmlns:r="http://schemas.openxmlformats.org/officeDocument/2006/relationships">
+<p:sld xmlns:a="http://schemas.openxmlformats.org/drawingml/2006/main" xmlns:r="http://schemas.openxmlformats.org/officeDocument/2006/relationships" xmlns:p="http://schemas.openxmlformats.org/presentationml/2006/main">
   <p:cSld>
     <p:bg>
       <p:bgPr>
@@ -6953,7 +7035,14 @@
         <p:cNvGrpSpPr/>
         <p:nvPr/>
       </p:nvGrpSpPr>
-      <p:grpSpPr/>
+      <p:grpSpPr>
+        <a:xfrm>
+          <a:off x="0" y="0"/>
+          <a:ext cx="0" cy="0"/>
+          <a:chOff x="0" y="0"/>
+          <a:chExt cx="0" cy="0"/>
+        </a:xfrm>
+      </p:grpSpPr>
       <p:sp>
         <p:nvSpPr>
           <p:cNvPr id="2" name="Rectangle 1"/>
@@ -6994,6 +7083,7 @@
           <a:lstStyle/>
           <a:p>
             <a:pPr algn="ctr"/>
+            <a:endParaRPr/>
           </a:p>
         </p:txBody>
       </p:sp>
@@ -7037,6 +7127,7 @@
           <a:lstStyle/>
           <a:p>
             <a:pPr algn="ctr"/>
+            <a:endParaRPr/>
           </a:p>
         </p:txBody>
       </p:sp>
@@ -7147,6 +7238,7 @@
           <a:lstStyle/>
           <a:p>
             <a:pPr algn="ctr"/>
+            <a:endParaRPr/>
           </a:p>
         </p:txBody>
       </p:sp>
@@ -7244,6 +7336,7 @@
           <a:lstStyle/>
           <a:p>
             <a:pPr algn="ctr"/>
+            <a:endParaRPr/>
           </a:p>
         </p:txBody>
       </p:sp>
@@ -7429,6 +7522,7 @@
           <a:lstStyle/>
           <a:p>
             <a:pPr algn="ctr"/>
+            <a:endParaRPr/>
           </a:p>
         </p:txBody>
       </p:sp>
@@ -7442,7 +7536,7 @@
         </p:nvGraphicFramePr>
         <p:xfrm>
           <a:off x="5733288" y="2688336"/>
-          <a:ext cx="5662879" cy="2304288"/>
+          <a:ext cx="5662879" cy="2395728"/>
         </p:xfrm>
         <a:graphic>
           <a:graphicData uri="http://schemas.openxmlformats.org/drawingml/2006/table">
@@ -7451,12 +7545,48 @@
                 <a:tableStyleId>{5C22544A-7EE6-4342-B048-85BDC9FD1C3A}</a:tableStyleId>
               </a:tblPr>
               <a:tblGrid>
-                <a:gridCol w="943813"/>
-                <a:gridCol w="943813"/>
-                <a:gridCol w="943813"/>
-                <a:gridCol w="943813"/>
-                <a:gridCol w="943813"/>
-                <a:gridCol w="943814"/>
+                <a:gridCol w="943813">
+                  <a:extLst>
+                    <a:ext uri="{9D8B030D-6E8A-4147-A177-3AD203B41FA5}">
+                      <a16:colId xmlns:a16="http://schemas.microsoft.com/office/drawing/2014/main" val="20000"/>
+                    </a:ext>
+                  </a:extLst>
+                </a:gridCol>
+                <a:gridCol w="943813">
+                  <a:extLst>
+                    <a:ext uri="{9D8B030D-6E8A-4147-A177-3AD203B41FA5}">
+                      <a16:colId xmlns:a16="http://schemas.microsoft.com/office/drawing/2014/main" val="20001"/>
+                    </a:ext>
+                  </a:extLst>
+                </a:gridCol>
+                <a:gridCol w="943813">
+                  <a:extLst>
+                    <a:ext uri="{9D8B030D-6E8A-4147-A177-3AD203B41FA5}">
+                      <a16:colId xmlns:a16="http://schemas.microsoft.com/office/drawing/2014/main" val="20002"/>
+                    </a:ext>
+                  </a:extLst>
+                </a:gridCol>
+                <a:gridCol w="943813">
+                  <a:extLst>
+                    <a:ext uri="{9D8B030D-6E8A-4147-A177-3AD203B41FA5}">
+                      <a16:colId xmlns:a16="http://schemas.microsoft.com/office/drawing/2014/main" val="20003"/>
+                    </a:ext>
+                  </a:extLst>
+                </a:gridCol>
+                <a:gridCol w="943813">
+                  <a:extLst>
+                    <a:ext uri="{9D8B030D-6E8A-4147-A177-3AD203B41FA5}">
+                      <a16:colId xmlns:a16="http://schemas.microsoft.com/office/drawing/2014/main" val="20004"/>
+                    </a:ext>
+                  </a:extLst>
+                </a:gridCol>
+                <a:gridCol w="943814">
+                  <a:extLst>
+                    <a:ext uri="{9D8B030D-6E8A-4147-A177-3AD203B41FA5}">
+                      <a16:colId xmlns:a16="http://schemas.microsoft.com/office/drawing/2014/main" val="20005"/>
+                    </a:ext>
+                  </a:extLst>
+                </a:gridCol>
               </a:tblGrid>
               <a:tr h="384048">
                 <a:tc>
@@ -7603,6 +7733,11 @@
                     </a:solidFill>
                   </a:tcPr>
                 </a:tc>
+                <a:extLst>
+                  <a:ext uri="{0D108BD9-81ED-4DB2-BD59-A6C34878D82A}">
+                    <a16:rowId xmlns:a16="http://schemas.microsoft.com/office/drawing/2014/main" val="10000"/>
+                  </a:ext>
+                </a:extLst>
               </a:tr>
               <a:tr h="384048">
                 <a:tc>
@@ -7749,6 +7884,11 @@
                     </a:solidFill>
                   </a:tcPr>
                 </a:tc>
+                <a:extLst>
+                  <a:ext uri="{0D108BD9-81ED-4DB2-BD59-A6C34878D82A}">
+                    <a16:rowId xmlns:a16="http://schemas.microsoft.com/office/drawing/2014/main" val="10001"/>
+                  </a:ext>
+                </a:extLst>
               </a:tr>
               <a:tr h="384048">
                 <a:tc>
@@ -7895,6 +8035,11 @@
                     </a:solidFill>
                   </a:tcPr>
                 </a:tc>
+                <a:extLst>
+                  <a:ext uri="{0D108BD9-81ED-4DB2-BD59-A6C34878D82A}">
+                    <a16:rowId xmlns:a16="http://schemas.microsoft.com/office/drawing/2014/main" val="10002"/>
+                  </a:ext>
+                </a:extLst>
               </a:tr>
               <a:tr h="384048">
                 <a:tc>
@@ -8041,6 +8186,11 @@
                     </a:solidFill>
                   </a:tcPr>
                 </a:tc>
+                <a:extLst>
+                  <a:ext uri="{0D108BD9-81ED-4DB2-BD59-A6C34878D82A}">
+                    <a16:rowId xmlns:a16="http://schemas.microsoft.com/office/drawing/2014/main" val="10003"/>
+                  </a:ext>
+                </a:extLst>
               </a:tr>
               <a:tr h="384048">
                 <a:tc>
@@ -8187,6 +8337,11 @@
                     </a:solidFill>
                   </a:tcPr>
                 </a:tc>
+                <a:extLst>
+                  <a:ext uri="{0D108BD9-81ED-4DB2-BD59-A6C34878D82A}">
+                    <a16:rowId xmlns:a16="http://schemas.microsoft.com/office/drawing/2014/main" val="10004"/>
+                  </a:ext>
+                </a:extLst>
               </a:tr>
               <a:tr h="384048">
                 <a:tc>
@@ -8333,6 +8488,11 @@
                     </a:solidFill>
                   </a:tcPr>
                 </a:tc>
+                <a:extLst>
+                  <a:ext uri="{0D108BD9-81ED-4DB2-BD59-A6C34878D82A}">
+                    <a16:rowId xmlns:a16="http://schemas.microsoft.com/office/drawing/2014/main" val="10005"/>
+                  </a:ext>
+                </a:extLst>
               </a:tr>
             </a:tbl>
           </a:graphicData>
@@ -8347,7 +8507,7 @@
 </file>
 
 <file path=ppt/slides/slide18.xml><?xml version="1.0" encoding="utf-8"?>
-<p:sld xmlns:a="http://schemas.openxmlformats.org/drawingml/2006/main" xmlns:p="http://schemas.openxmlformats.org/presentationml/2006/main" xmlns:r="http://schemas.openxmlformats.org/officeDocument/2006/relationships">
+<p:sld xmlns:a="http://schemas.openxmlformats.org/drawingml/2006/main" xmlns:r="http://schemas.openxmlformats.org/officeDocument/2006/relationships" xmlns:p="http://schemas.openxmlformats.org/presentationml/2006/main">
   <p:cSld>
     <p:bg>
       <p:bgPr>
@@ -8363,7 +8523,14 @@
         <p:cNvGrpSpPr/>
         <p:nvPr/>
       </p:nvGrpSpPr>
-      <p:grpSpPr/>
+      <p:grpSpPr>
+        <a:xfrm>
+          <a:off x="0" y="0"/>
+          <a:ext cx="0" cy="0"/>
+          <a:chOff x="0" y="0"/>
+          <a:chExt cx="0" cy="0"/>
+        </a:xfrm>
+      </p:grpSpPr>
       <p:sp>
         <p:nvSpPr>
           <p:cNvPr id="2" name="Rectangle 1"/>
@@ -8404,6 +8571,7 @@
           <a:lstStyle/>
           <a:p>
             <a:pPr algn="ctr"/>
+            <a:endParaRPr/>
           </a:p>
         </p:txBody>
       </p:sp>
@@ -8447,6 +8615,7 @@
           <a:lstStyle/>
           <a:p>
             <a:pPr algn="ctr"/>
+            <a:endParaRPr/>
           </a:p>
         </p:txBody>
       </p:sp>
@@ -8557,6 +8726,7 @@
           <a:lstStyle/>
           <a:p>
             <a:pPr algn="ctr"/>
+            <a:endParaRPr/>
           </a:p>
         </p:txBody>
       </p:sp>
@@ -8654,6 +8824,7 @@
           <a:lstStyle/>
           <a:p>
             <a:pPr algn="ctr"/>
+            <a:endParaRPr/>
           </a:p>
         </p:txBody>
       </p:sp>
@@ -8735,7 +8906,7 @@
 </file>
 
 <file path=ppt/slides/slide19.xml><?xml version="1.0" encoding="utf-8"?>
-<p:sld xmlns:a="http://schemas.openxmlformats.org/drawingml/2006/main" xmlns:p="http://schemas.openxmlformats.org/presentationml/2006/main" xmlns:r="http://schemas.openxmlformats.org/officeDocument/2006/relationships">
+<p:sld xmlns:a="http://schemas.openxmlformats.org/drawingml/2006/main" xmlns:r="http://schemas.openxmlformats.org/officeDocument/2006/relationships" xmlns:p="http://schemas.openxmlformats.org/presentationml/2006/main">
   <p:cSld>
     <p:bg>
       <p:bgPr>
@@ -8751,7 +8922,14 @@
         <p:cNvGrpSpPr/>
         <p:nvPr/>
       </p:nvGrpSpPr>
-      <p:grpSpPr/>
+      <p:grpSpPr>
+        <a:xfrm>
+          <a:off x="0" y="0"/>
+          <a:ext cx="0" cy="0"/>
+          <a:chOff x="0" y="0"/>
+          <a:chExt cx="0" cy="0"/>
+        </a:xfrm>
+      </p:grpSpPr>
       <p:sp>
         <p:nvSpPr>
           <p:cNvPr id="2" name="Rectangle 1"/>
@@ -8792,6 +8970,7 @@
           <a:lstStyle/>
           <a:p>
             <a:pPr algn="ctr"/>
+            <a:endParaRPr/>
           </a:p>
         </p:txBody>
       </p:sp>
@@ -8835,6 +9014,7 @@
           <a:lstStyle/>
           <a:p>
             <a:pPr algn="ctr"/>
+            <a:endParaRPr/>
           </a:p>
         </p:txBody>
       </p:sp>
@@ -8945,6 +9125,7 @@
           <a:lstStyle/>
           <a:p>
             <a:pPr algn="ctr"/>
+            <a:endParaRPr/>
           </a:p>
         </p:txBody>
       </p:sp>
@@ -9042,6 +9223,7 @@
           <a:lstStyle/>
           <a:p>
             <a:pPr algn="ctr"/>
+            <a:endParaRPr/>
           </a:p>
         </p:txBody>
       </p:sp>
@@ -9337,6 +9519,7 @@
           <a:lstStyle/>
           <a:p>
             <a:pPr algn="ctr"/>
+            <a:endParaRPr/>
           </a:p>
         </p:txBody>
       </p:sp>
@@ -9548,7 +9731,7 @@
 </file>
 
 <file path=ppt/slides/slide2.xml><?xml version="1.0" encoding="utf-8"?>
-<p:sld xmlns:a="http://schemas.openxmlformats.org/drawingml/2006/main" xmlns:p="http://schemas.openxmlformats.org/presentationml/2006/main" xmlns:r="http://schemas.openxmlformats.org/officeDocument/2006/relationships">
+<p:sld xmlns:a="http://schemas.openxmlformats.org/drawingml/2006/main" xmlns:r="http://schemas.openxmlformats.org/officeDocument/2006/relationships" xmlns:p="http://schemas.openxmlformats.org/presentationml/2006/main">
   <p:cSld>
     <p:bg>
       <p:bgPr>
@@ -9564,7 +9747,14 @@
         <p:cNvGrpSpPr/>
         <p:nvPr/>
       </p:nvGrpSpPr>
-      <p:grpSpPr/>
+      <p:grpSpPr>
+        <a:xfrm>
+          <a:off x="0" y="0"/>
+          <a:ext cx="0" cy="0"/>
+          <a:chOff x="0" y="0"/>
+          <a:chExt cx="0" cy="0"/>
+        </a:xfrm>
+      </p:grpSpPr>
       <p:sp>
         <p:nvSpPr>
           <p:cNvPr id="2" name="Rectangle 1"/>
@@ -9605,6 +9795,7 @@
           <a:lstStyle/>
           <a:p>
             <a:pPr algn="ctr"/>
+            <a:endParaRPr/>
           </a:p>
         </p:txBody>
       </p:sp>
@@ -9648,6 +9839,7 @@
           <a:lstStyle/>
           <a:p>
             <a:pPr algn="ctr"/>
+            <a:endParaRPr/>
           </a:p>
         </p:txBody>
       </p:sp>
@@ -9727,7 +9919,7 @@
 </file>
 
 <file path=ppt/slides/slide20.xml><?xml version="1.0" encoding="utf-8"?>
-<p:sld xmlns:a="http://schemas.openxmlformats.org/drawingml/2006/main" xmlns:p="http://schemas.openxmlformats.org/presentationml/2006/main" xmlns:r="http://schemas.openxmlformats.org/officeDocument/2006/relationships">
+<p:sld xmlns:a="http://schemas.openxmlformats.org/drawingml/2006/main" xmlns:r="http://schemas.openxmlformats.org/officeDocument/2006/relationships" xmlns:p="http://schemas.openxmlformats.org/presentationml/2006/main">
   <p:cSld>
     <p:bg>
       <p:bgPr>
@@ -9743,7 +9935,14 @@
         <p:cNvGrpSpPr/>
         <p:nvPr/>
       </p:nvGrpSpPr>
-      <p:grpSpPr/>
+      <p:grpSpPr>
+        <a:xfrm>
+          <a:off x="0" y="0"/>
+          <a:ext cx="0" cy="0"/>
+          <a:chOff x="0" y="0"/>
+          <a:chExt cx="0" cy="0"/>
+        </a:xfrm>
+      </p:grpSpPr>
       <p:sp>
         <p:nvSpPr>
           <p:cNvPr id="2" name="Rectangle 1"/>
@@ -9784,6 +9983,7 @@
           <a:lstStyle/>
           <a:p>
             <a:pPr algn="ctr"/>
+            <a:endParaRPr/>
           </a:p>
         </p:txBody>
       </p:sp>
@@ -9827,6 +10027,7 @@
           <a:lstStyle/>
           <a:p>
             <a:pPr algn="ctr"/>
+            <a:endParaRPr/>
           </a:p>
         </p:txBody>
       </p:sp>
@@ -9937,6 +10138,7 @@
           <a:lstStyle/>
           <a:p>
             <a:pPr algn="ctr"/>
+            <a:endParaRPr/>
           </a:p>
         </p:txBody>
       </p:sp>
@@ -10034,6 +10236,7 @@
           <a:lstStyle/>
           <a:p>
             <a:pPr algn="ctr"/>
+            <a:endParaRPr/>
           </a:p>
         </p:txBody>
       </p:sp>
@@ -10351,6 +10554,7 @@
           <a:lstStyle/>
           <a:p>
             <a:pPr algn="ctr"/>
+            <a:endParaRPr/>
           </a:p>
         </p:txBody>
       </p:sp>
@@ -10387,7 +10591,7 @@
 </file>
 
 <file path=ppt/slides/slide21.xml><?xml version="1.0" encoding="utf-8"?>
-<p:sld xmlns:a="http://schemas.openxmlformats.org/drawingml/2006/main" xmlns:p="http://schemas.openxmlformats.org/presentationml/2006/main" xmlns:r="http://schemas.openxmlformats.org/officeDocument/2006/relationships">
+<p:sld xmlns:a="http://schemas.openxmlformats.org/drawingml/2006/main" xmlns:r="http://schemas.openxmlformats.org/officeDocument/2006/relationships" xmlns:p="http://schemas.openxmlformats.org/presentationml/2006/main">
   <p:cSld>
     <p:bg>
       <p:bgPr>
@@ -10403,7 +10607,14 @@
         <p:cNvGrpSpPr/>
         <p:nvPr/>
       </p:nvGrpSpPr>
-      <p:grpSpPr/>
+      <p:grpSpPr>
+        <a:xfrm>
+          <a:off x="0" y="0"/>
+          <a:ext cx="0" cy="0"/>
+          <a:chOff x="0" y="0"/>
+          <a:chExt cx="0" cy="0"/>
+        </a:xfrm>
+      </p:grpSpPr>
       <p:sp>
         <p:nvSpPr>
           <p:cNvPr id="2" name="Rectangle 1"/>
@@ -10444,6 +10655,7 @@
           <a:lstStyle/>
           <a:p>
             <a:pPr algn="ctr"/>
+            <a:endParaRPr/>
           </a:p>
         </p:txBody>
       </p:sp>
@@ -10487,6 +10699,7 @@
           <a:lstStyle/>
           <a:p>
             <a:pPr algn="ctr"/>
+            <a:endParaRPr/>
           </a:p>
         </p:txBody>
       </p:sp>
@@ -10597,6 +10810,7 @@
           <a:lstStyle/>
           <a:p>
             <a:pPr algn="ctr"/>
+            <a:endParaRPr/>
           </a:p>
         </p:txBody>
       </p:sp>
@@ -10694,6 +10908,7 @@
           <a:lstStyle/>
           <a:p>
             <a:pPr algn="ctr"/>
+            <a:endParaRPr/>
           </a:p>
         </p:txBody>
       </p:sp>
@@ -10945,6 +11160,7 @@
           <a:lstStyle/>
           <a:p>
             <a:pPr algn="ctr"/>
+            <a:endParaRPr/>
           </a:p>
         </p:txBody>
       </p:sp>
@@ -10981,7 +11197,7 @@
 </file>
 
 <file path=ppt/slides/slide22.xml><?xml version="1.0" encoding="utf-8"?>
-<p:sld xmlns:a="http://schemas.openxmlformats.org/drawingml/2006/main" xmlns:p="http://schemas.openxmlformats.org/presentationml/2006/main" xmlns:r="http://schemas.openxmlformats.org/officeDocument/2006/relationships">
+<p:sld xmlns:a="http://schemas.openxmlformats.org/drawingml/2006/main" xmlns:r="http://schemas.openxmlformats.org/officeDocument/2006/relationships" xmlns:p="http://schemas.openxmlformats.org/presentationml/2006/main">
   <p:cSld>
     <p:bg>
       <p:bgPr>
@@ -10997,7 +11213,14 @@
         <p:cNvGrpSpPr/>
         <p:nvPr/>
       </p:nvGrpSpPr>
-      <p:grpSpPr/>
+      <p:grpSpPr>
+        <a:xfrm>
+          <a:off x="0" y="0"/>
+          <a:ext cx="0" cy="0"/>
+          <a:chOff x="0" y="0"/>
+          <a:chExt cx="0" cy="0"/>
+        </a:xfrm>
+      </p:grpSpPr>
       <p:sp>
         <p:nvSpPr>
           <p:cNvPr id="2" name="Rectangle 1"/>
@@ -11038,6 +11261,7 @@
           <a:lstStyle/>
           <a:p>
             <a:pPr algn="ctr"/>
+            <a:endParaRPr/>
           </a:p>
         </p:txBody>
       </p:sp>
@@ -11081,6 +11305,7 @@
           <a:lstStyle/>
           <a:p>
             <a:pPr algn="ctr"/>
+            <a:endParaRPr/>
           </a:p>
         </p:txBody>
       </p:sp>
@@ -11191,6 +11416,7 @@
           <a:lstStyle/>
           <a:p>
             <a:pPr algn="ctr"/>
+            <a:endParaRPr/>
           </a:p>
         </p:txBody>
       </p:sp>
@@ -11288,6 +11514,7 @@
           <a:lstStyle/>
           <a:p>
             <a:pPr algn="ctr"/>
+            <a:endParaRPr/>
           </a:p>
         </p:txBody>
       </p:sp>
@@ -11561,6 +11788,7 @@
           <a:lstStyle/>
           <a:p>
             <a:pPr algn="ctr"/>
+            <a:endParaRPr/>
           </a:p>
         </p:txBody>
       </p:sp>
@@ -11597,7 +11825,7 @@
 </file>
 
 <file path=ppt/slides/slide23.xml><?xml version="1.0" encoding="utf-8"?>
-<p:sld xmlns:a="http://schemas.openxmlformats.org/drawingml/2006/main" xmlns:p="http://schemas.openxmlformats.org/presentationml/2006/main" xmlns:r="http://schemas.openxmlformats.org/officeDocument/2006/relationships">
+<p:sld xmlns:a="http://schemas.openxmlformats.org/drawingml/2006/main" xmlns:r="http://schemas.openxmlformats.org/officeDocument/2006/relationships" xmlns:p="http://schemas.openxmlformats.org/presentationml/2006/main">
   <p:cSld>
     <p:bg>
       <p:bgPr>
@@ -11613,7 +11841,14 @@
         <p:cNvGrpSpPr/>
         <p:nvPr/>
       </p:nvGrpSpPr>
-      <p:grpSpPr/>
+      <p:grpSpPr>
+        <a:xfrm>
+          <a:off x="0" y="0"/>
+          <a:ext cx="0" cy="0"/>
+          <a:chOff x="0" y="0"/>
+          <a:chExt cx="0" cy="0"/>
+        </a:xfrm>
+      </p:grpSpPr>
       <p:sp>
         <p:nvSpPr>
           <p:cNvPr id="2" name="Rectangle 1"/>
@@ -11654,6 +11889,7 @@
           <a:lstStyle/>
           <a:p>
             <a:pPr algn="ctr"/>
+            <a:endParaRPr/>
           </a:p>
         </p:txBody>
       </p:sp>
@@ -11697,6 +11933,7 @@
           <a:lstStyle/>
           <a:p>
             <a:pPr algn="ctr"/>
+            <a:endParaRPr/>
           </a:p>
         </p:txBody>
       </p:sp>
@@ -11807,6 +12044,7 @@
           <a:lstStyle/>
           <a:p>
             <a:pPr algn="ctr"/>
+            <a:endParaRPr/>
           </a:p>
         </p:txBody>
       </p:sp>
@@ -11904,6 +12142,7 @@
           <a:lstStyle/>
           <a:p>
             <a:pPr algn="ctr"/>
+            <a:endParaRPr/>
           </a:p>
         </p:txBody>
       </p:sp>
@@ -12111,6 +12350,7 @@
           <a:lstStyle/>
           <a:p>
             <a:pPr algn="ctr"/>
+            <a:endParaRPr/>
           </a:p>
         </p:txBody>
       </p:sp>
@@ -12147,7 +12387,7 @@
 </file>
 
 <file path=ppt/slides/slide24.xml><?xml version="1.0" encoding="utf-8"?>
-<p:sld xmlns:a="http://schemas.openxmlformats.org/drawingml/2006/main" xmlns:p="http://schemas.openxmlformats.org/presentationml/2006/main" xmlns:r="http://schemas.openxmlformats.org/officeDocument/2006/relationships">
+<p:sld xmlns:a="http://schemas.openxmlformats.org/drawingml/2006/main" xmlns:r="http://schemas.openxmlformats.org/officeDocument/2006/relationships" xmlns:p="http://schemas.openxmlformats.org/presentationml/2006/main">
   <p:cSld>
     <p:bg>
       <p:bgPr>
@@ -12163,7 +12403,14 @@
         <p:cNvGrpSpPr/>
         <p:nvPr/>
       </p:nvGrpSpPr>
-      <p:grpSpPr/>
+      <p:grpSpPr>
+        <a:xfrm>
+          <a:off x="0" y="0"/>
+          <a:ext cx="0" cy="0"/>
+          <a:chOff x="0" y="0"/>
+          <a:chExt cx="0" cy="0"/>
+        </a:xfrm>
+      </p:grpSpPr>
       <p:sp>
         <p:nvSpPr>
           <p:cNvPr id="2" name="Rectangle 1"/>
@@ -12204,6 +12451,7 @@
           <a:lstStyle/>
           <a:p>
             <a:pPr algn="ctr"/>
+            <a:endParaRPr/>
           </a:p>
         </p:txBody>
       </p:sp>
@@ -12247,6 +12495,7 @@
           <a:lstStyle/>
           <a:p>
             <a:pPr algn="ctr"/>
+            <a:endParaRPr/>
           </a:p>
         </p:txBody>
       </p:sp>
@@ -12357,6 +12606,7 @@
           <a:lstStyle/>
           <a:p>
             <a:pPr algn="ctr"/>
+            <a:endParaRPr/>
           </a:p>
         </p:txBody>
       </p:sp>
@@ -12454,6 +12704,7 @@
           <a:lstStyle/>
           <a:p>
             <a:pPr algn="ctr"/>
+            <a:endParaRPr/>
           </a:p>
         </p:txBody>
       </p:sp>
@@ -12683,6 +12934,7 @@
           <a:lstStyle/>
           <a:p>
             <a:pPr algn="ctr"/>
+            <a:endParaRPr/>
           </a:p>
         </p:txBody>
       </p:sp>
@@ -12719,7 +12971,7 @@
 </file>
 
 <file path=ppt/slides/slide25.xml><?xml version="1.0" encoding="utf-8"?>
-<p:sld xmlns:a="http://schemas.openxmlformats.org/drawingml/2006/main" xmlns:p="http://schemas.openxmlformats.org/presentationml/2006/main" xmlns:r="http://schemas.openxmlformats.org/officeDocument/2006/relationships">
+<p:sld xmlns:a="http://schemas.openxmlformats.org/drawingml/2006/main" xmlns:r="http://schemas.openxmlformats.org/officeDocument/2006/relationships" xmlns:p="http://schemas.openxmlformats.org/presentationml/2006/main">
   <p:cSld>
     <p:bg>
       <p:bgPr>
@@ -12735,7 +12987,14 @@
         <p:cNvGrpSpPr/>
         <p:nvPr/>
       </p:nvGrpSpPr>
-      <p:grpSpPr/>
+      <p:grpSpPr>
+        <a:xfrm>
+          <a:off x="0" y="0"/>
+          <a:ext cx="0" cy="0"/>
+          <a:chOff x="0" y="0"/>
+          <a:chExt cx="0" cy="0"/>
+        </a:xfrm>
+      </p:grpSpPr>
       <p:sp>
         <p:nvSpPr>
           <p:cNvPr id="2" name="Rectangle 1"/>
@@ -12776,6 +13035,7 @@
           <a:lstStyle/>
           <a:p>
             <a:pPr algn="ctr"/>
+            <a:endParaRPr/>
           </a:p>
         </p:txBody>
       </p:sp>
@@ -12819,6 +13079,7 @@
           <a:lstStyle/>
           <a:p>
             <a:pPr algn="ctr"/>
+            <a:endParaRPr/>
           </a:p>
         </p:txBody>
       </p:sp>
@@ -12929,6 +13190,7 @@
           <a:lstStyle/>
           <a:p>
             <a:pPr algn="ctr"/>
+            <a:endParaRPr/>
           </a:p>
         </p:txBody>
       </p:sp>
@@ -13026,6 +13288,7 @@
           <a:lstStyle/>
           <a:p>
             <a:pPr algn="ctr"/>
+            <a:endParaRPr/>
           </a:p>
         </p:txBody>
       </p:sp>
@@ -13303,7 +13566,7 @@
 </file>
 
 <file path=ppt/slides/slide26.xml><?xml version="1.0" encoding="utf-8"?>
-<p:sld xmlns:a="http://schemas.openxmlformats.org/drawingml/2006/main" xmlns:p="http://schemas.openxmlformats.org/presentationml/2006/main" xmlns:r="http://schemas.openxmlformats.org/officeDocument/2006/relationships">
+<p:sld xmlns:a="http://schemas.openxmlformats.org/drawingml/2006/main" xmlns:r="http://schemas.openxmlformats.org/officeDocument/2006/relationships" xmlns:p="http://schemas.openxmlformats.org/presentationml/2006/main">
   <p:cSld>
     <p:bg>
       <p:bgPr>
@@ -13319,7 +13582,14 @@
         <p:cNvGrpSpPr/>
         <p:nvPr/>
       </p:nvGrpSpPr>
-      <p:grpSpPr/>
+      <p:grpSpPr>
+        <a:xfrm>
+          <a:off x="0" y="0"/>
+          <a:ext cx="0" cy="0"/>
+          <a:chOff x="0" y="0"/>
+          <a:chExt cx="0" cy="0"/>
+        </a:xfrm>
+      </p:grpSpPr>
       <p:sp>
         <p:nvSpPr>
           <p:cNvPr id="2" name="Rectangle 1"/>
@@ -13360,6 +13630,7 @@
           <a:lstStyle/>
           <a:p>
             <a:pPr algn="ctr"/>
+            <a:endParaRPr/>
           </a:p>
         </p:txBody>
       </p:sp>
@@ -13403,6 +13674,7 @@
           <a:lstStyle/>
           <a:p>
             <a:pPr algn="ctr"/>
+            <a:endParaRPr/>
           </a:p>
         </p:txBody>
       </p:sp>
@@ -13482,7 +13754,7 @@
 </file>
 
 <file path=ppt/slides/slide27.xml><?xml version="1.0" encoding="utf-8"?>
-<p:sld xmlns:a="http://schemas.openxmlformats.org/drawingml/2006/main" xmlns:p="http://schemas.openxmlformats.org/presentationml/2006/main" xmlns:r="http://schemas.openxmlformats.org/officeDocument/2006/relationships">
+<p:sld xmlns:a="http://schemas.openxmlformats.org/drawingml/2006/main" xmlns:r="http://schemas.openxmlformats.org/officeDocument/2006/relationships" xmlns:p="http://schemas.openxmlformats.org/presentationml/2006/main">
   <p:cSld>
     <p:bg>
       <p:bgPr>
@@ -13498,7 +13770,14 @@
         <p:cNvGrpSpPr/>
         <p:nvPr/>
       </p:nvGrpSpPr>
-      <p:grpSpPr/>
+      <p:grpSpPr>
+        <a:xfrm>
+          <a:off x="0" y="0"/>
+          <a:ext cx="0" cy="0"/>
+          <a:chOff x="0" y="0"/>
+          <a:chExt cx="0" cy="0"/>
+        </a:xfrm>
+      </p:grpSpPr>
       <p:sp>
         <p:nvSpPr>
           <p:cNvPr id="2" name="Rectangle 1"/>
@@ -13539,6 +13818,7 @@
           <a:lstStyle/>
           <a:p>
             <a:pPr algn="ctr"/>
+            <a:endParaRPr/>
           </a:p>
         </p:txBody>
       </p:sp>
@@ -13582,6 +13862,7 @@
           <a:lstStyle/>
           <a:p>
             <a:pPr algn="ctr"/>
+            <a:endParaRPr/>
           </a:p>
         </p:txBody>
       </p:sp>
@@ -13692,6 +13973,7 @@
           <a:lstStyle/>
           <a:p>
             <a:pPr algn="ctr"/>
+            <a:endParaRPr/>
           </a:p>
         </p:txBody>
       </p:sp>
@@ -13789,6 +14071,7 @@
           <a:lstStyle/>
           <a:p>
             <a:pPr algn="ctr"/>
+            <a:endParaRPr/>
           </a:p>
         </p:txBody>
       </p:sp>
@@ -13996,6 +14279,7 @@
           <a:lstStyle/>
           <a:p>
             <a:pPr algn="ctr"/>
+            <a:endParaRPr/>
           </a:p>
         </p:txBody>
       </p:sp>
@@ -14201,7 +14485,7 @@
 </file>
 
 <file path=ppt/slides/slide28.xml><?xml version="1.0" encoding="utf-8"?>
-<p:sld xmlns:a="http://schemas.openxmlformats.org/drawingml/2006/main" xmlns:p="http://schemas.openxmlformats.org/presentationml/2006/main" xmlns:r="http://schemas.openxmlformats.org/officeDocument/2006/relationships">
+<p:sld xmlns:a="http://schemas.openxmlformats.org/drawingml/2006/main" xmlns:r="http://schemas.openxmlformats.org/officeDocument/2006/relationships" xmlns:p="http://schemas.openxmlformats.org/presentationml/2006/main">
   <p:cSld>
     <p:bg>
       <p:bgPr>
@@ -14217,7 +14501,14 @@
         <p:cNvGrpSpPr/>
         <p:nvPr/>
       </p:nvGrpSpPr>
-      <p:grpSpPr/>
+      <p:grpSpPr>
+        <a:xfrm>
+          <a:off x="0" y="0"/>
+          <a:ext cx="0" cy="0"/>
+          <a:chOff x="0" y="0"/>
+          <a:chExt cx="0" cy="0"/>
+        </a:xfrm>
+      </p:grpSpPr>
       <p:sp>
         <p:nvSpPr>
           <p:cNvPr id="2" name="Rectangle 1"/>
@@ -14258,6 +14549,7 @@
           <a:lstStyle/>
           <a:p>
             <a:pPr algn="ctr"/>
+            <a:endParaRPr/>
           </a:p>
         </p:txBody>
       </p:sp>
@@ -14301,6 +14593,7 @@
           <a:lstStyle/>
           <a:p>
             <a:pPr algn="ctr"/>
+            <a:endParaRPr/>
           </a:p>
         </p:txBody>
       </p:sp>
@@ -14411,6 +14704,7 @@
           <a:lstStyle/>
           <a:p>
             <a:pPr algn="ctr"/>
+            <a:endParaRPr/>
           </a:p>
         </p:txBody>
       </p:sp>
@@ -14508,6 +14802,7 @@
           <a:lstStyle/>
           <a:p>
             <a:pPr algn="ctr"/>
+            <a:endParaRPr/>
           </a:p>
         </p:txBody>
       </p:sp>
@@ -14763,7 +15058,7 @@
 </file>
 
 <file path=ppt/slides/slide29.xml><?xml version="1.0" encoding="utf-8"?>
-<p:sld xmlns:a="http://schemas.openxmlformats.org/drawingml/2006/main" xmlns:p="http://schemas.openxmlformats.org/presentationml/2006/main" xmlns:r="http://schemas.openxmlformats.org/officeDocument/2006/relationships">
+<p:sld xmlns:a="http://schemas.openxmlformats.org/drawingml/2006/main" xmlns:r="http://schemas.openxmlformats.org/officeDocument/2006/relationships" xmlns:p="http://schemas.openxmlformats.org/presentationml/2006/main">
   <p:cSld>
     <p:bg>
       <p:bgPr>
@@ -14779,7 +15074,14 @@
         <p:cNvGrpSpPr/>
         <p:nvPr/>
       </p:nvGrpSpPr>
-      <p:grpSpPr/>
+      <p:grpSpPr>
+        <a:xfrm>
+          <a:off x="0" y="0"/>
+          <a:ext cx="0" cy="0"/>
+          <a:chOff x="0" y="0"/>
+          <a:chExt cx="0" cy="0"/>
+        </a:xfrm>
+      </p:grpSpPr>
       <p:sp>
         <p:nvSpPr>
           <p:cNvPr id="2" name="Rectangle 1"/>
@@ -14820,6 +15122,7 @@
           <a:lstStyle/>
           <a:p>
             <a:pPr algn="ctr"/>
+            <a:endParaRPr/>
           </a:p>
         </p:txBody>
       </p:sp>
@@ -14863,6 +15166,7 @@
           <a:lstStyle/>
           <a:p>
             <a:pPr algn="ctr"/>
+            <a:endParaRPr/>
           </a:p>
         </p:txBody>
       </p:sp>
@@ -15061,6 +15365,7 @@
           <a:lstStyle/>
           <a:p>
             <a:pPr algn="ctr"/>
+            <a:endParaRPr/>
           </a:p>
         </p:txBody>
       </p:sp>
@@ -15118,7 +15423,7 @@
 </file>
 
 <file path=ppt/slides/slide3.xml><?xml version="1.0" encoding="utf-8"?>
-<p:sld xmlns:a="http://schemas.openxmlformats.org/drawingml/2006/main" xmlns:p="http://schemas.openxmlformats.org/presentationml/2006/main" xmlns:r="http://schemas.openxmlformats.org/officeDocument/2006/relationships">
+<p:sld xmlns:a="http://schemas.openxmlformats.org/drawingml/2006/main" xmlns:r="http://schemas.openxmlformats.org/officeDocument/2006/relationships" xmlns:p="http://schemas.openxmlformats.org/presentationml/2006/main">
   <p:cSld>
     <p:bg>
       <p:bgPr>
@@ -15134,7 +15439,14 @@
         <p:cNvGrpSpPr/>
         <p:nvPr/>
       </p:nvGrpSpPr>
-      <p:grpSpPr/>
+      <p:grpSpPr>
+        <a:xfrm>
+          <a:off x="0" y="0"/>
+          <a:ext cx="0" cy="0"/>
+          <a:chOff x="0" y="0"/>
+          <a:chExt cx="0" cy="0"/>
+        </a:xfrm>
+      </p:grpSpPr>
       <p:sp>
         <p:nvSpPr>
           <p:cNvPr id="2" name="Rectangle 1"/>
@@ -15175,6 +15487,7 @@
           <a:lstStyle/>
           <a:p>
             <a:pPr algn="ctr"/>
+            <a:endParaRPr/>
           </a:p>
         </p:txBody>
       </p:sp>
@@ -15218,6 +15531,7 @@
           <a:lstStyle/>
           <a:p>
             <a:pPr algn="ctr"/>
+            <a:endParaRPr/>
           </a:p>
         </p:txBody>
       </p:sp>
@@ -15328,6 +15642,7 @@
           <a:lstStyle/>
           <a:p>
             <a:pPr algn="ctr"/>
+            <a:endParaRPr/>
           </a:p>
         </p:txBody>
       </p:sp>
@@ -15425,6 +15740,7 @@
           <a:lstStyle/>
           <a:p>
             <a:pPr algn="ctr"/>
+            <a:endParaRPr/>
           </a:p>
         </p:txBody>
       </p:sp>
@@ -15698,6 +16014,7 @@
           <a:lstStyle/>
           <a:p>
             <a:pPr algn="ctr"/>
+            <a:endParaRPr/>
           </a:p>
         </p:txBody>
       </p:sp>
@@ -15734,7 +16051,7 @@
 </file>
 
 <file path=ppt/slides/slide4.xml><?xml version="1.0" encoding="utf-8"?>
-<p:sld xmlns:a="http://schemas.openxmlformats.org/drawingml/2006/main" xmlns:p="http://schemas.openxmlformats.org/presentationml/2006/main" xmlns:r="http://schemas.openxmlformats.org/officeDocument/2006/relationships">
+<p:sld xmlns:a="http://schemas.openxmlformats.org/drawingml/2006/main" xmlns:r="http://schemas.openxmlformats.org/officeDocument/2006/relationships" xmlns:p="http://schemas.openxmlformats.org/presentationml/2006/main">
   <p:cSld>
     <p:bg>
       <p:bgPr>
@@ -15750,7 +16067,14 @@
         <p:cNvGrpSpPr/>
         <p:nvPr/>
       </p:nvGrpSpPr>
-      <p:grpSpPr/>
+      <p:grpSpPr>
+        <a:xfrm>
+          <a:off x="0" y="0"/>
+          <a:ext cx="0" cy="0"/>
+          <a:chOff x="0" y="0"/>
+          <a:chExt cx="0" cy="0"/>
+        </a:xfrm>
+      </p:grpSpPr>
       <p:sp>
         <p:nvSpPr>
           <p:cNvPr id="2" name="Rectangle 1"/>
@@ -15791,6 +16115,7 @@
           <a:lstStyle/>
           <a:p>
             <a:pPr algn="ctr"/>
+            <a:endParaRPr/>
           </a:p>
         </p:txBody>
       </p:sp>
@@ -15834,6 +16159,7 @@
           <a:lstStyle/>
           <a:p>
             <a:pPr algn="ctr"/>
+            <a:endParaRPr/>
           </a:p>
         </p:txBody>
       </p:sp>
@@ -15944,6 +16270,7 @@
           <a:lstStyle/>
           <a:p>
             <a:pPr algn="ctr"/>
+            <a:endParaRPr/>
           </a:p>
         </p:txBody>
       </p:sp>
@@ -16041,6 +16368,7 @@
           <a:lstStyle/>
           <a:p>
             <a:pPr algn="ctr"/>
+            <a:endParaRPr/>
           </a:p>
         </p:txBody>
       </p:sp>
@@ -16252,6 +16580,7 @@
           <a:lstStyle/>
           <a:p>
             <a:pPr algn="ctr"/>
+            <a:endParaRPr/>
           </a:p>
         </p:txBody>
       </p:sp>
@@ -16288,7 +16617,7 @@
 </file>
 
 <file path=ppt/slides/slide5.xml><?xml version="1.0" encoding="utf-8"?>
-<p:sld xmlns:a="http://schemas.openxmlformats.org/drawingml/2006/main" xmlns:p="http://schemas.openxmlformats.org/presentationml/2006/main" xmlns:r="http://schemas.openxmlformats.org/officeDocument/2006/relationships">
+<p:sld xmlns:a="http://schemas.openxmlformats.org/drawingml/2006/main" xmlns:r="http://schemas.openxmlformats.org/officeDocument/2006/relationships" xmlns:p="http://schemas.openxmlformats.org/presentationml/2006/main">
   <p:cSld>
     <p:bg>
       <p:bgPr>
@@ -16304,7 +16633,14 @@
         <p:cNvGrpSpPr/>
         <p:nvPr/>
       </p:nvGrpSpPr>
-      <p:grpSpPr/>
+      <p:grpSpPr>
+        <a:xfrm>
+          <a:off x="0" y="0"/>
+          <a:ext cx="0" cy="0"/>
+          <a:chOff x="0" y="0"/>
+          <a:chExt cx="0" cy="0"/>
+        </a:xfrm>
+      </p:grpSpPr>
       <p:sp>
         <p:nvSpPr>
           <p:cNvPr id="2" name="Rectangle 1"/>
@@ -16345,6 +16681,7 @@
           <a:lstStyle/>
           <a:p>
             <a:pPr algn="ctr"/>
+            <a:endParaRPr/>
           </a:p>
         </p:txBody>
       </p:sp>
@@ -16388,6 +16725,7 @@
           <a:lstStyle/>
           <a:p>
             <a:pPr algn="ctr"/>
+            <a:endParaRPr/>
           </a:p>
         </p:txBody>
       </p:sp>
@@ -16498,6 +16836,7 @@
           <a:lstStyle/>
           <a:p>
             <a:pPr algn="ctr"/>
+            <a:endParaRPr/>
           </a:p>
         </p:txBody>
       </p:sp>
@@ -16595,6 +16934,7 @@
           <a:lstStyle/>
           <a:p>
             <a:pPr algn="ctr"/>
+            <a:endParaRPr/>
           </a:p>
         </p:txBody>
       </p:sp>
@@ -16802,6 +17142,7 @@
           <a:lstStyle/>
           <a:p>
             <a:pPr algn="ctr"/>
+            <a:endParaRPr/>
           </a:p>
         </p:txBody>
       </p:sp>
@@ -16838,7 +17179,7 @@
 </file>
 
 <file path=ppt/slides/slide6.xml><?xml version="1.0" encoding="utf-8"?>
-<p:sld xmlns:a="http://schemas.openxmlformats.org/drawingml/2006/main" xmlns:p="http://schemas.openxmlformats.org/presentationml/2006/main" xmlns:r="http://schemas.openxmlformats.org/officeDocument/2006/relationships">
+<p:sld xmlns:a="http://schemas.openxmlformats.org/drawingml/2006/main" xmlns:r="http://schemas.openxmlformats.org/officeDocument/2006/relationships" xmlns:p="http://schemas.openxmlformats.org/presentationml/2006/main">
   <p:cSld>
     <p:bg>
       <p:bgPr>
@@ -16854,7 +17195,14 @@
         <p:cNvGrpSpPr/>
         <p:nvPr/>
       </p:nvGrpSpPr>
-      <p:grpSpPr/>
+      <p:grpSpPr>
+        <a:xfrm>
+          <a:off x="0" y="0"/>
+          <a:ext cx="0" cy="0"/>
+          <a:chOff x="0" y="0"/>
+          <a:chExt cx="0" cy="0"/>
+        </a:xfrm>
+      </p:grpSpPr>
       <p:sp>
         <p:nvSpPr>
           <p:cNvPr id="2" name="Rectangle 1"/>
@@ -16895,6 +17243,7 @@
           <a:lstStyle/>
           <a:p>
             <a:pPr algn="ctr"/>
+            <a:endParaRPr/>
           </a:p>
         </p:txBody>
       </p:sp>
@@ -16938,6 +17287,7 @@
           <a:lstStyle/>
           <a:p>
             <a:pPr algn="ctr"/>
+            <a:endParaRPr/>
           </a:p>
         </p:txBody>
       </p:sp>
@@ -17048,6 +17398,7 @@
           <a:lstStyle/>
           <a:p>
             <a:pPr algn="ctr"/>
+            <a:endParaRPr/>
           </a:p>
         </p:txBody>
       </p:sp>
@@ -17145,6 +17496,7 @@
           <a:lstStyle/>
           <a:p>
             <a:pPr algn="ctr"/>
+            <a:endParaRPr/>
           </a:p>
         </p:txBody>
       </p:sp>
@@ -17352,6 +17704,7 @@
           <a:lstStyle/>
           <a:p>
             <a:pPr algn="ctr"/>
+            <a:endParaRPr/>
           </a:p>
         </p:txBody>
       </p:sp>
@@ -17388,7 +17741,7 @@
 </file>
 
 <file path=ppt/slides/slide7.xml><?xml version="1.0" encoding="utf-8"?>
-<p:sld xmlns:a="http://schemas.openxmlformats.org/drawingml/2006/main" xmlns:p="http://schemas.openxmlformats.org/presentationml/2006/main" xmlns:r="http://schemas.openxmlformats.org/officeDocument/2006/relationships">
+<p:sld xmlns:a="http://schemas.openxmlformats.org/drawingml/2006/main" xmlns:r="http://schemas.openxmlformats.org/officeDocument/2006/relationships" xmlns:p="http://schemas.openxmlformats.org/presentationml/2006/main">
   <p:cSld>
     <p:bg>
       <p:bgPr>
@@ -17404,7 +17757,14 @@
         <p:cNvGrpSpPr/>
         <p:nvPr/>
       </p:nvGrpSpPr>
-      <p:grpSpPr/>
+      <p:grpSpPr>
+        <a:xfrm>
+          <a:off x="0" y="0"/>
+          <a:ext cx="0" cy="0"/>
+          <a:chOff x="0" y="0"/>
+          <a:chExt cx="0" cy="0"/>
+        </a:xfrm>
+      </p:grpSpPr>
       <p:sp>
         <p:nvSpPr>
           <p:cNvPr id="2" name="Rectangle 1"/>
@@ -17445,6 +17805,7 @@
           <a:lstStyle/>
           <a:p>
             <a:pPr algn="ctr"/>
+            <a:endParaRPr/>
           </a:p>
         </p:txBody>
       </p:sp>
@@ -17488,6 +17849,7 @@
           <a:lstStyle/>
           <a:p>
             <a:pPr algn="ctr"/>
+            <a:endParaRPr/>
           </a:p>
         </p:txBody>
       </p:sp>
@@ -17598,6 +17960,7 @@
           <a:lstStyle/>
           <a:p>
             <a:pPr algn="ctr"/>
+            <a:endParaRPr/>
           </a:p>
         </p:txBody>
       </p:sp>
@@ -17695,6 +18058,7 @@
           <a:lstStyle/>
           <a:p>
             <a:pPr algn="ctr"/>
+            <a:endParaRPr/>
           </a:p>
         </p:txBody>
       </p:sp>
@@ -17880,6 +18244,7 @@
           <a:lstStyle/>
           <a:p>
             <a:pPr algn="ctr"/>
+            <a:endParaRPr/>
           </a:p>
         </p:txBody>
       </p:sp>
@@ -17916,7 +18281,7 @@
 </file>
 
 <file path=ppt/slides/slide8.xml><?xml version="1.0" encoding="utf-8"?>
-<p:sld xmlns:a="http://schemas.openxmlformats.org/drawingml/2006/main" xmlns:p="http://schemas.openxmlformats.org/presentationml/2006/main" xmlns:r="http://schemas.openxmlformats.org/officeDocument/2006/relationships">
+<p:sld xmlns:a="http://schemas.openxmlformats.org/drawingml/2006/main" xmlns:r="http://schemas.openxmlformats.org/officeDocument/2006/relationships" xmlns:p="http://schemas.openxmlformats.org/presentationml/2006/main">
   <p:cSld>
     <p:bg>
       <p:bgPr>
@@ -17932,7 +18297,14 @@
         <p:cNvGrpSpPr/>
         <p:nvPr/>
       </p:nvGrpSpPr>
-      <p:grpSpPr/>
+      <p:grpSpPr>
+        <a:xfrm>
+          <a:off x="0" y="0"/>
+          <a:ext cx="0" cy="0"/>
+          <a:chOff x="0" y="0"/>
+          <a:chExt cx="0" cy="0"/>
+        </a:xfrm>
+      </p:grpSpPr>
       <p:sp>
         <p:nvSpPr>
           <p:cNvPr id="2" name="Rectangle 1"/>
@@ -17973,6 +18345,7 @@
           <a:lstStyle/>
           <a:p>
             <a:pPr algn="ctr"/>
+            <a:endParaRPr/>
           </a:p>
         </p:txBody>
       </p:sp>
@@ -18016,6 +18389,7 @@
           <a:lstStyle/>
           <a:p>
             <a:pPr algn="ctr"/>
+            <a:endParaRPr/>
           </a:p>
         </p:txBody>
       </p:sp>
@@ -18126,6 +18500,7 @@
           <a:lstStyle/>
           <a:p>
             <a:pPr algn="ctr"/>
+            <a:endParaRPr/>
           </a:p>
         </p:txBody>
       </p:sp>
@@ -18223,6 +18598,7 @@
           <a:lstStyle/>
           <a:p>
             <a:pPr algn="ctr"/>
+            <a:endParaRPr/>
           </a:p>
         </p:txBody>
       </p:sp>
@@ -18408,6 +18784,7 @@
           <a:lstStyle/>
           <a:p>
             <a:pPr algn="ctr"/>
+            <a:endParaRPr/>
           </a:p>
         </p:txBody>
       </p:sp>
@@ -18444,7 +18821,7 @@
 </file>
 
 <file path=ppt/slides/slide9.xml><?xml version="1.0" encoding="utf-8"?>
-<p:sld xmlns:a="http://schemas.openxmlformats.org/drawingml/2006/main" xmlns:p="http://schemas.openxmlformats.org/presentationml/2006/main" xmlns:r="http://schemas.openxmlformats.org/officeDocument/2006/relationships">
+<p:sld xmlns:a="http://schemas.openxmlformats.org/drawingml/2006/main" xmlns:r="http://schemas.openxmlformats.org/officeDocument/2006/relationships" xmlns:p="http://schemas.openxmlformats.org/presentationml/2006/main">
   <p:cSld>
     <p:bg>
       <p:bgPr>
@@ -18460,7 +18837,14 @@
         <p:cNvGrpSpPr/>
         <p:nvPr/>
       </p:nvGrpSpPr>
-      <p:grpSpPr/>
+      <p:grpSpPr>
+        <a:xfrm>
+          <a:off x="0" y="0"/>
+          <a:ext cx="0" cy="0"/>
+          <a:chOff x="0" y="0"/>
+          <a:chExt cx="0" cy="0"/>
+        </a:xfrm>
+      </p:grpSpPr>
       <p:sp>
         <p:nvSpPr>
           <p:cNvPr id="2" name="Rectangle 1"/>
@@ -18501,6 +18885,7 @@
           <a:lstStyle/>
           <a:p>
             <a:pPr algn="ctr"/>
+            <a:endParaRPr/>
           </a:p>
         </p:txBody>
       </p:sp>
@@ -18544,6 +18929,7 @@
           <a:lstStyle/>
           <a:p>
             <a:pPr algn="ctr"/>
+            <a:endParaRPr/>
           </a:p>
         </p:txBody>
       </p:sp>
@@ -18654,6 +19040,7 @@
           <a:lstStyle/>
           <a:p>
             <a:pPr algn="ctr"/>
+            <a:endParaRPr/>
           </a:p>
         </p:txBody>
       </p:sp>
@@ -18751,6 +19138,7 @@
           <a:lstStyle/>
           <a:p>
             <a:pPr algn="ctr"/>
+            <a:endParaRPr/>
           </a:p>
         </p:txBody>
       </p:sp>
@@ -18936,6 +19324,7 @@
           <a:lstStyle/>
           <a:p>
             <a:pPr algn="ctr"/>
+            <a:endParaRPr/>
           </a:p>
         </p:txBody>
       </p:sp>

</xml_diff>